<commit_message>
Fix author name Azimjon → Azimzhon  in presentation
</commit_message>
<xml_diff>
--- a/docs/Presentation_SmartLearn.pptx
+++ b/docs/Presentation_SmartLearn.pptx
@@ -1729,7 +1729,7 @@
                 <a:ea typeface="Calibri" pitchFamily="34" charset="-122"/>
                 <a:cs typeface="Calibri" pitchFamily="34" charset="-120"/>
               </a:rPr>
-              <a:t>Bachelor's Thesis  ·  Riga Nordic University  ·  2025</a:t>
+              <a:t>Bachelor's Thesis  ·  Riga Nordic University  ·  2026</a:t>
             </a:r>
             <a:br>
               <a:rPr lang="en-US" sz="1400" dirty="0">
@@ -1846,7 +1846,7 @@
                 <a:ea typeface="Calibri" pitchFamily="34" charset="-122"/>
                 <a:cs typeface="Calibri" pitchFamily="34" charset="-120"/>
               </a:rPr>
-              <a:t>Azimjon</a:t>
+              <a:t>Azimzhon</a:t>
             </a:r>
             <a:endParaRPr lang="en-US" sz="1400" dirty="0"/>
           </a:p>
@@ -6313,7 +6313,7 @@
               <a:t> </a:t>
             </a:r>
             <a:r>
-              <a:rPr lang="en-US" sz="1600" dirty="0" err="1">
+              <a:rPr lang="en-US" sz="1600">
                 <a:solidFill>
                   <a:srgbClr val="333333"/>
                 </a:solidFill>
@@ -6321,7 +6321,7 @@
                 <a:ea typeface="Calibri" pitchFamily="34" charset="-122"/>
                 <a:cs typeface="Calibri" pitchFamily="34" charset="-120"/>
               </a:rPr>
-              <a:t>Azimjon</a:t>
+              <a:t>Azimzhon</a:t>
             </a:r>
             <a:endParaRPr lang="en-US" sz="1600" dirty="0"/>
           </a:p>

</xml_diff>